<commit_message>
Start the build in Session 17 and move setup-guide writing out of Session 20
- Session 17: "the build starts today" with a walking skeleton (new slide 4,
  outline, student page); Session 18 builds the slice on it
- Session 20 v3: guide written before class, 30-min cold test, plan revision
  after class; student page, 15-slide deck, MVP Plan Review sheet
- MVP Plan: say the Nov 11 revision is the version CP10 scores
- Args tables: escape inline HTML so Submit lines keep their spaces
  (MVP Plan, CP7, CP10, CP3/CP5 drafts)
- Blocker board leaves Session 20; it is introduced in Session 21
- Prop Loft session-20 publish moved before Session 19 in the checklist

Co-Authored-By: Claude Opus 5.5 <noreply@anthropic.com>
</commit_message>
<xml_diff>
--- a/canvas_material/lectures/powerpoint/Session18-SizeFitOrder.pptx
+++ b/canvas_material/lectures/powerpoint/Session18-SizeFitOrder.pptx
@@ -1844,7 +1844,7 @@
           <a:p>
             <a:r>
               <a:rPr lang="en-US" dirty="0"/>
-              <a:t>Close in a minute or two. Say the one-liner. The slice statement is now the progress-demo script, and the next cut is already decided, so the midpoint check next Wednesday is a yes-or-no question: is the skateboard walking? Monday is MVP thinking and debugging, right before the heaviest build fortnight. Keep the Fit Check Sheet; it's a working copy, not a turn-in.</a:t>
+              <a:t>Close in a minute or two. Say the one-liner. The slice statement is now the progress-demo script, and the next cut is already decided, so the midpoint check next Wednesday is a yes-or-no question: is the skateboard walking? Then the build step, out loud: the skeleton from Monday merges this week, and the first slice issue is in progress on top of it before Monday. Show of hands on skeletons. Monday is MVP thinking and debugging, right before the heaviest build fortnight. Keep the Fit Check Sheet; it's a working copy, not a turn-in.</a:t>
             </a:r>
             <a:endParaRPr lang="en-US" dirty="0"/>
           </a:p>
@@ -19814,7 +19814,7 @@
                 <a:ea typeface="Calibri" pitchFamily="34" charset="-122"/>
                 <a:cs typeface="Calibri" pitchFamily="34" charset="-120"/>
               </a:rPr>
-              <a:t>Start the first slice issue; have it in progress before Monday</a:t>
+              <a:t>Merge your walking skeleton, then start the first slice issue on it; in progress before Monday</a:t>
             </a:r>
             <a:endParaRPr lang="en-US" sz="1700" dirty="0"/>
           </a:p>

</xml_diff>